<commit_message>
Add comprehensive pipeline guide for PanNET bipartite GNN
- Introduced `PIPELINE_GUIDE.md`, detailing the methodology, dataset, and processing stages for the PanNET bipartite GNN pipeline.
- Included sections on problem definition, dataset characteristics, core ideas, and step-by-step processing stages from WSI to graph construction.
- Updated `PanNET_Pipeline_Presentation.pptx` to reflect the latest changes in the pipeline documentation.
</commit_message>
<xml_diff>
--- a/PanNET_Pipeline_Presentation.pptx
+++ b/PanNET_Pipeline_Presentation.pptx
@@ -9500,6 +9500,7 @@
               </a:defRPr>
             </a:pPr>
             <a:r>
+              <a:rPr dirty="0"/>
               <a:t>KEY INSIGHT</a:t>
             </a:r>
           </a:p>
@@ -9512,6 +9513,7 @@
               </a:defRPr>
             </a:pPr>
             <a:r>
+              <a:rPr dirty="0"/>
               <a:t>Infiltration is a SPATIAL property — it depends on HOW tumor interacts with surrounding tissue (NNP), not just what tumor cells look like individually. This is why GNNs are needed: they model spatial relationships between tissue patches.</a:t>
             </a:r>
           </a:p>
@@ -9559,7 +9561,7 @@
         <p:spPr>
           <a:xfrm>
             <a:off x="457200" y="274320"/>
-            <a:ext cx="10972800" cy="548640"/>
+            <a:ext cx="10972800" cy="523220"/>
           </a:xfrm>
           <a:prstGeom prst="rect">
             <a:avLst/>
@@ -9581,7 +9583,8 @@
               </a:defRPr>
             </a:pPr>
             <a:r>
-              <a:t>End-to-End Pipeline Overview</a:t>
+              <a:rPr dirty="0"/>
+              <a:t>Pipeline Overview</a:t>
             </a:r>
           </a:p>
         </p:txBody>
@@ -9753,10 +9756,14 @@
               </a:defRPr>
             </a:pPr>
             <a:r>
+              <a:rPr dirty="0"/>
               <a:t>Tissue</a:t>
             </a:r>
-            <a:br/>
-            <a:r>
+            <a:br>
+              <a:rPr dirty="0"/>
+            </a:br>
+            <a:r>
+              <a:rPr dirty="0"/>
               <a:t>Segmentation</a:t>
             </a:r>
           </a:p>
@@ -9769,10 +9776,14 @@
               </a:defRPr>
             </a:pPr>
             <a:r>
+              <a:rPr dirty="0" err="1"/>
               <a:t>GrandQC</a:t>
             </a:r>
-            <a:br/>
-            <a:r>
+            <a:br>
+              <a:rPr dirty="0"/>
+            </a:br>
+            <a:r>
+              <a:rPr dirty="0"/>
               <a:t>≥60% tissue</a:t>
             </a:r>
           </a:p>
@@ -9871,10 +9882,14 @@
               </a:defRPr>
             </a:pPr>
             <a:r>
+              <a:rPr dirty="0"/>
               <a:t>Patch</a:t>
             </a:r>
-            <a:br/>
-            <a:r>
+            <a:br>
+              <a:rPr dirty="0"/>
+            </a:br>
+            <a:r>
+              <a:rPr dirty="0"/>
               <a:t>Extraction</a:t>
             </a:r>
           </a:p>
@@ -9887,10 +9902,18 @@
               </a:defRPr>
             </a:pPr>
             <a:r>
-              <a:t>1024×1024 px</a:t>
-            </a:r>
-            <a:br/>
-            <a:r>
+              <a:rPr dirty="0"/>
+              <a:t>1024×1024 </a:t>
+            </a:r>
+            <a:r>
+              <a:rPr dirty="0" err="1"/>
+              <a:t>px</a:t>
+            </a:r>
+            <a:br>
+              <a:rPr dirty="0"/>
+            </a:br>
+            <a:r>
+              <a:rPr dirty="0"/>
               <a:t>@ 40x mag</a:t>
             </a:r>
           </a:p>
@@ -9989,10 +10012,14 @@
               </a:defRPr>
             </a:pPr>
             <a:r>
+              <a:rPr dirty="0"/>
               <a:t>VirChow2</a:t>
             </a:r>
-            <a:br/>
-            <a:r>
+            <a:br>
+              <a:rPr dirty="0"/>
+            </a:br>
+            <a:r>
+              <a:rPr dirty="0"/>
               <a:t>Encoder</a:t>
             </a:r>
           </a:p>
@@ -10005,10 +10032,14 @@
               </a:defRPr>
             </a:pPr>
             <a:r>
+              <a:rPr dirty="0"/>
               <a:t>Foundation model</a:t>
             </a:r>
-            <a:br/>
-            <a:r>
+            <a:br>
+              <a:rPr dirty="0"/>
+            </a:br>
+            <a:r>
+              <a:rPr dirty="0"/>
               <a:t>→ 1280-d vector</a:t>
             </a:r>
           </a:p>
@@ -10107,10 +10138,14 @@
               </a:defRPr>
             </a:pPr>
             <a:r>
+              <a:rPr dirty="0"/>
               <a:t>H5 File</a:t>
             </a:r>
-            <a:br/>
-            <a:r>
+            <a:br>
+              <a:rPr dirty="0"/>
+            </a:br>
+            <a:r>
+              <a:rPr dirty="0"/>
               <a:t>Output</a:t>
             </a:r>
           </a:p>
@@ -10123,10 +10158,14 @@
               </a:defRPr>
             </a:pPr>
             <a:r>
+              <a:rPr dirty="0"/>
               <a:t>features (N,1280)</a:t>
             </a:r>
-            <a:br/>
-            <a:r>
+            <a:br>
+              <a:rPr dirty="0"/>
+            </a:br>
+            <a:r>
+              <a:rPr dirty="0"/>
               <a:t>coords (N,2)</a:t>
             </a:r>
           </a:p>
@@ -10297,27 +10336,15 @@
               </a:defRPr>
             </a:pPr>
             <a:r>
+              <a:rPr dirty="0" err="1"/>
               <a:t>AutoEncoder</a:t>
             </a:r>
-            <a:br/>
-            <a:r>
+            <a:br>
+              <a:rPr dirty="0"/>
+            </a:br>
+            <a:r>
+              <a:rPr dirty="0"/>
               <a:t>(frozen)</a:t>
-            </a:r>
-          </a:p>
-          <a:p>
-            <a:pPr algn="ctr">
-              <a:defRPr sz="1100">
-                <a:solidFill>
-                  <a:srgbClr val="555566"/>
-                </a:solidFill>
-              </a:defRPr>
-            </a:pPr>
-            <a:r>
-              <a:t>1280 → 768 → 512</a:t>
-            </a:r>
-            <a:br/>
-            <a:r>
-              <a:t>→ 256-d latent</a:t>
             </a:r>
           </a:p>
         </p:txBody>
@@ -10415,10 +10442,14 @@
               </a:defRPr>
             </a:pPr>
             <a:r>
+              <a:rPr dirty="0"/>
               <a:t>Patch</a:t>
             </a:r>
-            <a:br/>
-            <a:r>
+            <a:br>
+              <a:rPr dirty="0"/>
+            </a:br>
+            <a:r>
+              <a:rPr dirty="0"/>
               <a:t>Classifier</a:t>
             </a:r>
           </a:p>
@@ -10431,11 +10462,23 @@
               </a:defRPr>
             </a:pPr>
             <a:r>
+              <a:rPr dirty="0"/>
               <a:t>3-class MLP</a:t>
             </a:r>
-            <a:br/>
-            <a:r>
-              <a:t>Stroma/PanNET/Normal</a:t>
+            <a:br>
+              <a:rPr dirty="0"/>
+            </a:br>
+            <a:r>
+              <a:rPr dirty="0"/>
+              <a:t>Stroma/</a:t>
+            </a:r>
+            <a:r>
+              <a:rPr dirty="0" err="1"/>
+              <a:t>PanNET</a:t>
+            </a:r>
+            <a:r>
+              <a:rPr dirty="0"/>
+              <a:t>/Normal</a:t>
             </a:r>
           </a:p>
         </p:txBody>
@@ -10533,10 +10576,14 @@
               </a:defRPr>
             </a:pPr>
             <a:r>
+              <a:rPr dirty="0"/>
               <a:t>Border</a:t>
             </a:r>
-            <a:br/>
-            <a:r>
+            <a:br>
+              <a:rPr dirty="0"/>
+            </a:br>
+            <a:r>
+              <a:rPr dirty="0"/>
               <a:t>Detection</a:t>
             </a:r>
           </a:p>
@@ -10549,10 +10596,14 @@
               </a:defRPr>
             </a:pPr>
             <a:r>
+              <a:rPr dirty="0"/>
               <a:t>8-connected check</a:t>
             </a:r>
-            <a:br/>
-            <a:r>
+            <a:br>
+              <a:rPr dirty="0"/>
+            </a:br>
+            <a:r>
+              <a:rPr dirty="0"/>
               <a:t>+ NNP neighbors</a:t>
             </a:r>
           </a:p>
@@ -11461,8 +11512,8 @@
         </p:nvSpPr>
         <p:spPr>
           <a:xfrm>
-            <a:off x="457200" y="274320"/>
-            <a:ext cx="4572000" cy="548640"/>
+            <a:off x="457199" y="274320"/>
+            <a:ext cx="6205993" cy="523220"/>
           </a:xfrm>
           <a:prstGeom prst="rect">
             <a:avLst/>
@@ -11484,7 +11535,16 @@
               </a:defRPr>
             </a:pPr>
             <a:r>
-              <a:t>Stage 1: WSI → Feature Extraction</a:t>
+              <a:rPr dirty="0"/>
+              <a:t>Stage 1: </a:t>
+            </a:r>
+            <a:r>
+              <a:rPr lang="tr-TR" dirty="0" err="1"/>
+              <a:t>Patch</a:t>
+            </a:r>
+            <a:r>
+              <a:rPr dirty="0"/>
+              <a:t> → Feature Extraction</a:t>
             </a:r>
           </a:p>
         </p:txBody>
@@ -11497,7 +11557,7 @@
         </p:nvSpPr>
         <p:spPr>
           <a:xfrm>
-            <a:off x="457200" y="1188720"/>
+            <a:off x="457199" y="1663698"/>
             <a:ext cx="3200400" cy="2286000"/>
           </a:xfrm>
           <a:prstGeom prst="roundRect">
@@ -11551,7 +11611,7 @@
         </p:nvSpPr>
         <p:spPr>
           <a:xfrm>
-            <a:off x="640080" y="1828800"/>
+            <a:off x="768095" y="2235200"/>
             <a:ext cx="457200" cy="292608"/>
           </a:xfrm>
           <a:prstGeom prst="roundRect">
@@ -11595,7 +11655,7 @@
         </p:nvSpPr>
         <p:spPr>
           <a:xfrm>
-            <a:off x="1170432" y="1828800"/>
+            <a:off x="1298447" y="2235200"/>
             <a:ext cx="457200" cy="292608"/>
           </a:xfrm>
           <a:prstGeom prst="roundRect">
@@ -11639,7 +11699,7 @@
         </p:nvSpPr>
         <p:spPr>
           <a:xfrm>
-            <a:off x="1700784" y="1828800"/>
+            <a:off x="1828799" y="2235200"/>
             <a:ext cx="457200" cy="292608"/>
           </a:xfrm>
           <a:prstGeom prst="roundRect">
@@ -11683,7 +11743,7 @@
         </p:nvSpPr>
         <p:spPr>
           <a:xfrm>
-            <a:off x="2231136" y="1828800"/>
+            <a:off x="2359151" y="2235200"/>
             <a:ext cx="457200" cy="292608"/>
           </a:xfrm>
           <a:prstGeom prst="roundRect">
@@ -11727,7 +11787,7 @@
         </p:nvSpPr>
         <p:spPr>
           <a:xfrm>
-            <a:off x="2761488" y="1828800"/>
+            <a:off x="2889503" y="2235200"/>
             <a:ext cx="457200" cy="292608"/>
           </a:xfrm>
           <a:prstGeom prst="roundRect">
@@ -11771,7 +11831,7 @@
         </p:nvSpPr>
         <p:spPr>
           <a:xfrm>
-            <a:off x="640080" y="2194560"/>
+            <a:off x="768095" y="2600960"/>
             <a:ext cx="457200" cy="292608"/>
           </a:xfrm>
           <a:prstGeom prst="roundRect">
@@ -11815,7 +11875,7 @@
         </p:nvSpPr>
         <p:spPr>
           <a:xfrm>
-            <a:off x="1170432" y="2194560"/>
+            <a:off x="1298447" y="2600960"/>
             <a:ext cx="457200" cy="292608"/>
           </a:xfrm>
           <a:prstGeom prst="roundRect">
@@ -11859,7 +11919,7 @@
         </p:nvSpPr>
         <p:spPr>
           <a:xfrm>
-            <a:off x="1700784" y="2194560"/>
+            <a:off x="1828799" y="2600960"/>
             <a:ext cx="457200" cy="292608"/>
           </a:xfrm>
           <a:prstGeom prst="roundRect">
@@ -11903,7 +11963,7 @@
         </p:nvSpPr>
         <p:spPr>
           <a:xfrm>
-            <a:off x="2231136" y="2194560"/>
+            <a:off x="2359151" y="2600960"/>
             <a:ext cx="457200" cy="292608"/>
           </a:xfrm>
           <a:prstGeom prst="roundRect">
@@ -11947,7 +12007,7 @@
         </p:nvSpPr>
         <p:spPr>
           <a:xfrm>
-            <a:off x="2761488" y="2194560"/>
+            <a:off x="2889503" y="2600960"/>
             <a:ext cx="457200" cy="292608"/>
           </a:xfrm>
           <a:prstGeom prst="roundRect">
@@ -11991,7 +12051,7 @@
         </p:nvSpPr>
         <p:spPr>
           <a:xfrm>
-            <a:off x="640080" y="2560320"/>
+            <a:off x="768095" y="2966720"/>
             <a:ext cx="457200" cy="292608"/>
           </a:xfrm>
           <a:prstGeom prst="roundRect">
@@ -12035,7 +12095,7 @@
         </p:nvSpPr>
         <p:spPr>
           <a:xfrm>
-            <a:off x="1170432" y="2560320"/>
+            <a:off x="1298447" y="2966720"/>
             <a:ext cx="457200" cy="292608"/>
           </a:xfrm>
           <a:prstGeom prst="roundRect">
@@ -12079,7 +12139,7 @@
         </p:nvSpPr>
         <p:spPr>
           <a:xfrm>
-            <a:off x="1700784" y="2560320"/>
+            <a:off x="1828799" y="2966720"/>
             <a:ext cx="457200" cy="292608"/>
           </a:xfrm>
           <a:prstGeom prst="roundRect">
@@ -12123,7 +12183,7 @@
         </p:nvSpPr>
         <p:spPr>
           <a:xfrm>
-            <a:off x="2231136" y="2560320"/>
+            <a:off x="2359151" y="2966720"/>
             <a:ext cx="457200" cy="292608"/>
           </a:xfrm>
           <a:prstGeom prst="roundRect">
@@ -12167,7 +12227,7 @@
         </p:nvSpPr>
         <p:spPr>
           <a:xfrm>
-            <a:off x="2761488" y="2560320"/>
+            <a:off x="2889503" y="2966720"/>
             <a:ext cx="457200" cy="292608"/>
           </a:xfrm>
           <a:prstGeom prst="roundRect">
@@ -12211,7 +12271,7 @@
         </p:nvSpPr>
         <p:spPr>
           <a:xfrm>
-            <a:off x="640080" y="2926080"/>
+            <a:off x="768095" y="3332480"/>
             <a:ext cx="457200" cy="292608"/>
           </a:xfrm>
           <a:prstGeom prst="roundRect">
@@ -12255,7 +12315,7 @@
         </p:nvSpPr>
         <p:spPr>
           <a:xfrm>
-            <a:off x="1170432" y="2926080"/>
+            <a:off x="1298447" y="3332480"/>
             <a:ext cx="457200" cy="292608"/>
           </a:xfrm>
           <a:prstGeom prst="roundRect">
@@ -12299,7 +12359,7 @@
         </p:nvSpPr>
         <p:spPr>
           <a:xfrm>
-            <a:off x="1700784" y="2926080"/>
+            <a:off x="1828799" y="3332480"/>
             <a:ext cx="457200" cy="292608"/>
           </a:xfrm>
           <a:prstGeom prst="roundRect">
@@ -12343,7 +12403,7 @@
         </p:nvSpPr>
         <p:spPr>
           <a:xfrm>
-            <a:off x="2231136" y="2926080"/>
+            <a:off x="2359151" y="3332480"/>
             <a:ext cx="457200" cy="292608"/>
           </a:xfrm>
           <a:prstGeom prst="roundRect">
@@ -12387,7 +12447,7 @@
         </p:nvSpPr>
         <p:spPr>
           <a:xfrm>
-            <a:off x="2761488" y="2926080"/>
+            <a:off x="2889503" y="3332480"/>
             <a:ext cx="457200" cy="292608"/>
           </a:xfrm>
           <a:prstGeom prst="roundRect">
@@ -12431,7 +12491,7 @@
         </p:nvSpPr>
         <p:spPr>
           <a:xfrm>
-            <a:off x="457200" y="3749039"/>
+            <a:off x="585215" y="4155439"/>
             <a:ext cx="228600" cy="228600"/>
           </a:xfrm>
           <a:prstGeom prst="ellipse">
@@ -12475,7 +12535,7 @@
         </p:nvSpPr>
         <p:spPr>
           <a:xfrm>
-            <a:off x="731520" y="3749039"/>
+            <a:off x="859535" y="4155439"/>
             <a:ext cx="914400" cy="274320"/>
           </a:xfrm>
           <a:prstGeom prst="rect">
@@ -12511,7 +12571,7 @@
         </p:nvSpPr>
         <p:spPr>
           <a:xfrm>
-            <a:off x="1554480" y="3749039"/>
+            <a:off x="1682495" y="4155439"/>
             <a:ext cx="228600" cy="228600"/>
           </a:xfrm>
           <a:prstGeom prst="ellipse">
@@ -12555,7 +12615,7 @@
         </p:nvSpPr>
         <p:spPr>
           <a:xfrm>
-            <a:off x="1828800" y="3749039"/>
+            <a:off x="1956815" y="4155439"/>
             <a:ext cx="914400" cy="274320"/>
           </a:xfrm>
           <a:prstGeom prst="rect">
@@ -12591,7 +12651,7 @@
         </p:nvSpPr>
         <p:spPr>
           <a:xfrm>
-            <a:off x="2560320" y="3749039"/>
+            <a:off x="2688335" y="4155439"/>
             <a:ext cx="228600" cy="228600"/>
           </a:xfrm>
           <a:prstGeom prst="ellipse">
@@ -12635,7 +12695,7 @@
         </p:nvSpPr>
         <p:spPr>
           <a:xfrm>
-            <a:off x="2834640" y="3749039"/>
+            <a:off x="2962655" y="4155439"/>
             <a:ext cx="914400" cy="274320"/>
           </a:xfrm>
           <a:prstGeom prst="rect">
@@ -12671,7 +12731,7 @@
         </p:nvSpPr>
         <p:spPr>
           <a:xfrm>
-            <a:off x="3840480" y="2103120"/>
+            <a:off x="3968495" y="2509520"/>
             <a:ext cx="640080" cy="365760"/>
           </a:xfrm>
           <a:prstGeom prst="rightArrow">
@@ -12715,7 +12775,7 @@
         </p:nvSpPr>
         <p:spPr>
           <a:xfrm>
-            <a:off x="4663440" y="1188720"/>
+            <a:off x="4791455" y="1595120"/>
             <a:ext cx="2926080" cy="2743200"/>
           </a:xfrm>
           <a:prstGeom prst="roundRect">
@@ -12756,6 +12816,7 @@
               </a:defRPr>
             </a:pPr>
             <a:r>
+              <a:rPr dirty="0"/>
               <a:t>VirChow2</a:t>
             </a:r>
           </a:p>
@@ -12768,6 +12829,7 @@
               </a:defRPr>
             </a:pPr>
             <a:r>
+              <a:rPr dirty="0"/>
               <a:t>Foundation Model</a:t>
             </a:r>
           </a:p>
@@ -12775,61 +12837,60 @@
             <a:pPr algn="ctr">
               <a:defRPr sz="1100">
                 <a:solidFill>
-                  <a:srgbClr val="555566"/>
-                </a:solidFill>
-              </a:defRPr>
-            </a:pPr>
-            <a:r>
-              <a:t>Pre-trained on millions</a:t>
-            </a:r>
-            <a:br/>
-            <a:r>
-              <a:t>of pathology images</a:t>
-            </a:r>
+                  <a:srgbClr val="1A1A1A"/>
+                </a:solidFill>
+              </a:defRPr>
+            </a:pPr>
+            <a:endParaRPr dirty="0"/>
           </a:p>
           <a:p>
             <a:pPr algn="ctr">
               <a:defRPr sz="1100">
                 <a:solidFill>
-                  <a:srgbClr val="1A1A1A"/>
-                </a:solidFill>
-              </a:defRPr>
-            </a:pPr>
-            <a:endParaRPr/>
+                  <a:srgbClr val="555566"/>
+                </a:solidFill>
+              </a:defRPr>
+            </a:pPr>
+            <a:r>
+              <a:rPr dirty="0"/>
+              <a:t>Input: 1024×1024×3 patch</a:t>
+            </a:r>
           </a:p>
           <a:p>
             <a:pPr algn="ctr">
               <a:defRPr sz="1100">
                 <a:solidFill>
-                  <a:srgbClr val="555566"/>
-                </a:solidFill>
-              </a:defRPr>
-            </a:pPr>
-            <a:r>
-              <a:t>Input: 1024×1024×3 patch</a:t>
+                  <a:srgbClr val="27AE60"/>
+                </a:solidFill>
+              </a:defRPr>
+            </a:pPr>
+            <a:r>
+              <a:rPr dirty="0"/>
+              <a:t>Output: 1280-d vector</a:t>
             </a:r>
           </a:p>
           <a:p>
             <a:pPr algn="ctr">
               <a:defRPr sz="1100">
                 <a:solidFill>
-                  <a:srgbClr val="27AE60"/>
-                </a:solidFill>
-              </a:defRPr>
-            </a:pPr>
-            <a:r>
-              <a:t>Output: 1280-d vector</a:t>
-            </a:r>
+                  <a:srgbClr val="1A1A1A"/>
+                </a:solidFill>
+              </a:defRPr>
+            </a:pPr>
+            <a:endParaRPr dirty="0"/>
           </a:p>
           <a:p>
             <a:pPr algn="ctr">
               <a:defRPr sz="1100">
                 <a:solidFill>
-                  <a:srgbClr val="1A1A1A"/>
-                </a:solidFill>
-              </a:defRPr>
-            </a:pPr>
-            <a:endParaRPr/>
+                  <a:srgbClr val="555566"/>
+                </a:solidFill>
+              </a:defRPr>
+            </a:pPr>
+            <a:r>
+              <a:rPr dirty="0"/>
+              <a:t>Captures: cell morphology,</a:t>
+            </a:r>
           </a:p>
           <a:p>
             <a:pPr algn="ctr">
@@ -12840,18 +12901,7 @@
               </a:defRPr>
             </a:pPr>
             <a:r>
-              <a:t>Captures: cell morphology,</a:t>
-            </a:r>
-          </a:p>
-          <a:p>
-            <a:pPr algn="ctr">
-              <a:defRPr sz="1100">
-                <a:solidFill>
-                  <a:srgbClr val="555566"/>
-                </a:solidFill>
-              </a:defRPr>
-            </a:pPr>
-            <a:r>
+              <a:rPr dirty="0"/>
               <a:t>tissue structure, staining</a:t>
             </a:r>
           </a:p>
@@ -12865,7 +12915,7 @@
         </p:nvSpPr>
         <p:spPr>
           <a:xfrm>
-            <a:off x="7772400" y="2103120"/>
+            <a:off x="7900415" y="2509520"/>
             <a:ext cx="640080" cy="365760"/>
           </a:xfrm>
           <a:prstGeom prst="rightArrow">
@@ -12909,7 +12959,7 @@
         </p:nvSpPr>
         <p:spPr>
           <a:xfrm>
-            <a:off x="8595360" y="1188720"/>
+            <a:off x="8723375" y="1595120"/>
             <a:ext cx="3108960" cy="2743200"/>
           </a:xfrm>
           <a:prstGeom prst="roundRect">
@@ -12950,6 +13000,7 @@
               </a:defRPr>
             </a:pPr>
             <a:r>
+              <a:rPr dirty="0"/>
               <a:t>H5 File (per slide)</a:t>
             </a:r>
           </a:p>
@@ -12963,6 +13014,7 @@
               </a:defRPr>
             </a:pPr>
             <a:r>
+              <a:rPr dirty="0"/>
               <a:t>features     (N, 1280)</a:t>
             </a:r>
           </a:p>
@@ -12976,6 +13028,7 @@
               </a:defRPr>
             </a:pPr>
             <a:r>
+              <a:rPr dirty="0"/>
               <a:t>coords       (N, 2)</a:t>
             </a:r>
           </a:p>
@@ -12989,7 +13042,12 @@
               </a:defRPr>
             </a:pPr>
             <a:r>
-              <a:t>patch_classes (N,)</a:t>
+              <a:rPr dirty="0" err="1"/>
+              <a:t>patch_classes</a:t>
+            </a:r>
+            <a:r>
+              <a:rPr dirty="0"/>
+              <a:t> (N,)</a:t>
             </a:r>
           </a:p>
           <a:p>
@@ -13002,7 +13060,12 @@
               </a:defRPr>
             </a:pPr>
             <a:r>
-              <a:t>tissue_id    (N,)</a:t>
+              <a:rPr dirty="0" err="1"/>
+              <a:t>tissue_id</a:t>
+            </a:r>
+            <a:r>
+              <a:rPr dirty="0"/>
+              <a:t>    (N,)</a:t>
             </a:r>
           </a:p>
           <a:p>
@@ -13015,7 +13078,12 @@
               </a:defRPr>
             </a:pPr>
             <a:r>
-              <a:t>slide_width  scalar</a:t>
+              <a:rPr dirty="0" err="1"/>
+              <a:t>slide_width</a:t>
+            </a:r>
+            <a:r>
+              <a:rPr dirty="0"/>
+              <a:t>  scalar</a:t>
             </a:r>
           </a:p>
           <a:p>
@@ -13028,7 +13096,12 @@
               </a:defRPr>
             </a:pPr>
             <a:r>
-              <a:t>slide_height scalar</a:t>
+              <a:rPr dirty="0" err="1"/>
+              <a:t>slide_height</a:t>
+            </a:r>
+            <a:r>
+              <a:rPr dirty="0"/>
+              <a:t> scalar</a:t>
             </a:r>
           </a:p>
           <a:p>
@@ -13040,7 +13113,7 @@
                 <a:latin typeface="Consolas"/>
               </a:defRPr>
             </a:pPr>
-            <a:endParaRPr/>
+            <a:endParaRPr dirty="0"/>
           </a:p>
           <a:p>
             <a:pPr algn="l">
@@ -13052,6 +13125,7 @@
               </a:defRPr>
             </a:pPr>
             <a:r>
+              <a:rPr dirty="0"/>
               <a:t>252 slides → 252 H5 files</a:t>
             </a:r>
           </a:p>
@@ -13065,8 +13139,8 @@
         </p:nvSpPr>
         <p:spPr>
           <a:xfrm>
-            <a:off x="457200" y="4297680"/>
-            <a:ext cx="10972800" cy="2286000"/>
+            <a:off x="737615" y="4795521"/>
+            <a:ext cx="10972800" cy="556563"/>
           </a:xfrm>
           <a:prstGeom prst="rect">
             <a:avLst/>
@@ -13091,7 +13165,24 @@
               </a:defRPr>
             </a:pPr>
             <a:r>
-              <a:t>• 40x magnification  |  1024×1024 px patches  |  ≥60% tissue threshold  |  GrandQC segmentation</a:t>
+              <a:rPr dirty="0"/>
+              <a:t>• 40x magnification  |  1024×1024 </a:t>
+            </a:r>
+            <a:r>
+              <a:rPr dirty="0" err="1"/>
+              <a:t>px</a:t>
+            </a:r>
+            <a:r>
+              <a:rPr dirty="0"/>
+              <a:t> patches  |  ≥60% tissue threshold  |  </a:t>
+            </a:r>
+            <a:r>
+              <a:rPr dirty="0" err="1"/>
+              <a:t>GrandQC</a:t>
+            </a:r>
+            <a:r>
+              <a:rPr dirty="0"/>
+              <a:t> segmentation</a:t>
             </a:r>
           </a:p>
           <a:p>
@@ -13107,23 +13198,16 @@
               </a:defRPr>
             </a:pPr>
             <a:r>
-              <a:t>• Patch classifier: MLP (2560→256→128→3)  —  F1: PanNET 97.2%, Normal 96.2%, Stroma 90.9%</a:t>
-            </a:r>
-          </a:p>
-          <a:p>
-            <a:pPr>
-              <a:spcAft>
-                <a:spcPts val="459"/>
-              </a:spcAft>
-              <a:defRPr sz="1300" b="0">
-                <a:solidFill>
-                  <a:srgbClr val="555566"/>
-                </a:solidFill>
-                <a:latin typeface="Calibri"/>
-              </a:defRPr>
-            </a:pPr>
-            <a:r>
-              <a:t>• 3 = RGB color channels (Red, Green, Blue per pixel)</a:t>
+              <a:rPr dirty="0"/>
+              <a:t>• Patch classifier: MLP (2560→256→128→3)  —  F1: </a:t>
+            </a:r>
+            <a:r>
+              <a:rPr dirty="0" err="1"/>
+              <a:t>PanNET</a:t>
+            </a:r>
+            <a:r>
+              <a:rPr dirty="0"/>
+              <a:t> 97.2%, Normal 96.2%, Stroma 90.9%</a:t>
             </a:r>
           </a:p>
         </p:txBody>
@@ -13228,6 +13312,7 @@
               </a:defRPr>
             </a:pPr>
             <a:r>
+              <a:rPr dirty="0"/>
               <a:t>Why? 1280-d features → overfitting on small dataset (73 patients). Compress to 256-d.</a:t>
             </a:r>
           </a:p>
@@ -13241,7 +13326,7 @@
         </p:nvSpPr>
         <p:spPr>
           <a:xfrm>
-            <a:off x="731520" y="2788920"/>
+            <a:off x="2839720" y="2354580"/>
             <a:ext cx="1188720" cy="1371600"/>
           </a:xfrm>
           <a:prstGeom prst="roundRect">
@@ -13295,8 +13380,8 @@
         </p:nvSpPr>
         <p:spPr>
           <a:xfrm>
-            <a:off x="731520" y="2331720"/>
-            <a:ext cx="1188720" cy="457200"/>
+            <a:off x="2839720" y="1897380"/>
+            <a:ext cx="1188720" cy="400110"/>
           </a:xfrm>
           <a:prstGeom prst="rect">
             <a:avLst/>
@@ -13335,7 +13420,7 @@
         </p:nvSpPr>
         <p:spPr>
           <a:xfrm>
-            <a:off x="1920240" y="3383280"/>
+            <a:off x="4028440" y="2948940"/>
             <a:ext cx="137160" cy="182880"/>
           </a:xfrm>
           <a:prstGeom prst="rightArrow">
@@ -13379,7 +13464,7 @@
         </p:nvSpPr>
         <p:spPr>
           <a:xfrm>
-            <a:off x="2057400" y="2926080"/>
+            <a:off x="4165600" y="2491740"/>
             <a:ext cx="1188720" cy="1097280"/>
           </a:xfrm>
           <a:prstGeom prst="roundRect">
@@ -13433,7 +13518,7 @@
         </p:nvSpPr>
         <p:spPr>
           <a:xfrm>
-            <a:off x="3246120" y="3383280"/>
+            <a:off x="5354320" y="2948940"/>
             <a:ext cx="137160" cy="182880"/>
           </a:xfrm>
           <a:prstGeom prst="rightArrow">
@@ -13477,7 +13562,7 @@
         </p:nvSpPr>
         <p:spPr>
           <a:xfrm>
-            <a:off x="3383280" y="3063240"/>
+            <a:off x="5491480" y="2628900"/>
             <a:ext cx="1188720" cy="822960"/>
           </a:xfrm>
           <a:prstGeom prst="roundRect">
@@ -13531,7 +13616,7 @@
         </p:nvSpPr>
         <p:spPr>
           <a:xfrm>
-            <a:off x="4572000" y="3383280"/>
+            <a:off x="6680200" y="2948940"/>
             <a:ext cx="137160" cy="182880"/>
           </a:xfrm>
           <a:prstGeom prst="rightArrow">
@@ -13575,7 +13660,7 @@
         </p:nvSpPr>
         <p:spPr>
           <a:xfrm>
-            <a:off x="4709160" y="3154680"/>
+            <a:off x="6817360" y="2720340"/>
             <a:ext cx="1188720" cy="640080"/>
           </a:xfrm>
           <a:prstGeom prst="roundRect">
@@ -13629,8 +13714,8 @@
         </p:nvSpPr>
         <p:spPr>
           <a:xfrm>
-            <a:off x="4709160" y="2697480"/>
-            <a:ext cx="1188720" cy="457200"/>
+            <a:off x="6817360" y="2263140"/>
+            <a:ext cx="1188720" cy="400110"/>
           </a:xfrm>
           <a:prstGeom prst="rect">
             <a:avLst/>
@@ -13669,7 +13754,7 @@
         </p:nvSpPr>
         <p:spPr>
           <a:xfrm>
-            <a:off x="5897880" y="3383280"/>
+            <a:off x="8006080" y="2948940"/>
             <a:ext cx="137160" cy="182880"/>
           </a:xfrm>
           <a:prstGeom prst="rightArrow">
@@ -13713,7 +13798,7 @@
         </p:nvSpPr>
         <p:spPr>
           <a:xfrm>
-            <a:off x="6035040" y="3063240"/>
+            <a:off x="8143240" y="2628900"/>
             <a:ext cx="1188720" cy="822960"/>
           </a:xfrm>
           <a:prstGeom prst="roundRect">
@@ -13767,7 +13852,7 @@
         </p:nvSpPr>
         <p:spPr>
           <a:xfrm>
-            <a:off x="7223760" y="3383280"/>
+            <a:off x="9331960" y="2948940"/>
             <a:ext cx="137160" cy="182880"/>
           </a:xfrm>
           <a:prstGeom prst="rightArrow">
@@ -13811,7 +13896,7 @@
         </p:nvSpPr>
         <p:spPr>
           <a:xfrm>
-            <a:off x="7360920" y="2926080"/>
+            <a:off x="9469120" y="2491740"/>
             <a:ext cx="1188720" cy="1097280"/>
           </a:xfrm>
           <a:prstGeom prst="roundRect">
@@ -13865,7 +13950,7 @@
         </p:nvSpPr>
         <p:spPr>
           <a:xfrm>
-            <a:off x="8549640" y="3383280"/>
+            <a:off x="10657840" y="2948940"/>
             <a:ext cx="137160" cy="182880"/>
           </a:xfrm>
           <a:prstGeom prst="rightArrow">
@@ -13909,7 +13994,7 @@
         </p:nvSpPr>
         <p:spPr>
           <a:xfrm>
-            <a:off x="8686800" y="2788920"/>
+            <a:off x="10795000" y="2354580"/>
             <a:ext cx="1188720" cy="1371600"/>
           </a:xfrm>
           <a:prstGeom prst="roundRect">
@@ -13963,8 +14048,8 @@
         </p:nvSpPr>
         <p:spPr>
           <a:xfrm>
-            <a:off x="8686800" y="2331720"/>
-            <a:ext cx="1188720" cy="457200"/>
+            <a:off x="10795000" y="1897380"/>
+            <a:ext cx="1188720" cy="246221"/>
           </a:xfrm>
           <a:prstGeom prst="rect">
             <a:avLst/>
@@ -13999,8 +14084,8 @@
         </p:nvSpPr>
         <p:spPr>
           <a:xfrm>
-            <a:off x="731520" y="5029200"/>
-            <a:ext cx="4572000" cy="365760"/>
+            <a:off x="2839720" y="4594860"/>
+            <a:ext cx="4572000" cy="307777"/>
           </a:xfrm>
           <a:prstGeom prst="rect">
             <a:avLst/>
@@ -14035,7 +14120,7 @@
         </p:nvSpPr>
         <p:spPr>
           <a:xfrm>
-            <a:off x="5943600" y="5029200"/>
+            <a:off x="8051800" y="4594860"/>
             <a:ext cx="4572000" cy="365760"/>
           </a:xfrm>
           <a:prstGeom prst="rect">
@@ -14065,50 +14150,14 @@
       </p:sp>
       <p:sp>
         <p:nvSpPr>
-          <p:cNvPr id="22" name="TextBox 21"/>
-          <p:cNvSpPr txBox="1"/>
-          <p:nvPr/>
-        </p:nvSpPr>
-        <p:spPr>
-          <a:xfrm>
-            <a:off x="8686800" y="1371600"/>
-            <a:ext cx="3200400" cy="365760"/>
-          </a:xfrm>
-          <a:prstGeom prst="rect">
-            <a:avLst/>
-          </a:prstGeom>
-          <a:noFill/>
-        </p:spPr>
-        <p:txBody>
-          <a:bodyPr wrap="square">
-            <a:spAutoFit/>
-          </a:bodyPr>
-          <a:lstStyle/>
-          <a:p>
-            <a:pPr algn="l">
-              <a:defRPr sz="1800" b="1">
-                <a:solidFill>
-                  <a:srgbClr val="1A1A1A"/>
-                </a:solidFill>
-                <a:latin typeface="Calibri"/>
-              </a:defRPr>
-            </a:pPr>
-            <a:r>
-              <a:t>Training Details</a:t>
-            </a:r>
-          </a:p>
-        </p:txBody>
-      </p:sp>
-      <p:sp>
-        <p:nvSpPr>
           <p:cNvPr id="23" name="TextBox 22"/>
           <p:cNvSpPr txBox="1"/>
           <p:nvPr/>
         </p:nvSpPr>
         <p:spPr>
           <a:xfrm>
-            <a:off x="8686800" y="1920240"/>
-            <a:ext cx="3200400" cy="3657600"/>
+            <a:off x="393700" y="1897380"/>
+            <a:ext cx="2377440" cy="3857466"/>
           </a:xfrm>
           <a:prstGeom prst="rect">
             <a:avLst/>
@@ -14133,7 +14182,8 @@
               </a:defRPr>
             </a:pPr>
             <a:r>
-              <a:t>Loss: MSE + variance reg</a:t>
+              <a:rPr lang="en-US" sz="1600" b="1" dirty="0"/>
+              <a:t>Training Details</a:t>
             </a:r>
           </a:p>
           <a:p>
@@ -14148,9 +14198,7 @@
                 <a:latin typeface="Calibri"/>
               </a:defRPr>
             </a:pPr>
-            <a:r>
-              <a:t>Optimizer: AdamW</a:t>
-            </a:r>
+            <a:endParaRPr lang="tr-TR" dirty="0"/>
           </a:p>
           <a:p>
             <a:pPr>
@@ -14165,7 +14213,8 @@
               </a:defRPr>
             </a:pPr>
             <a:r>
-              <a:t>LR: 1e-3, WD: 1e-4</a:t>
+              <a:rPr dirty="0"/>
+              <a:t>Loss: MSE + variance reg</a:t>
             </a:r>
           </a:p>
           <a:p>
@@ -14181,8 +14230,14 @@
               </a:defRPr>
             </a:pPr>
             <a:r>
-              <a:t>Batch size: 4096</a:t>
-            </a:r>
+              <a:rPr dirty="0"/>
+              <a:t>Optimizer: </a:t>
+            </a:r>
+            <a:r>
+              <a:rPr dirty="0" err="1"/>
+              <a:t>AdamW</a:t>
+            </a:r>
+            <a:endParaRPr dirty="0"/>
           </a:p>
           <a:p>
             <a:pPr>
@@ -14197,7 +14252,8 @@
               </a:defRPr>
             </a:pPr>
             <a:r>
-              <a:t>Epochs: 50</a:t>
+              <a:rPr dirty="0"/>
+              <a:t>LR: 1e-3, WD: 1e-4</a:t>
             </a:r>
           </a:p>
           <a:p>
@@ -14213,7 +14269,8 @@
               </a:defRPr>
             </a:pPr>
             <a:r>
-              <a:t>Early stopping: patience 10</a:t>
+              <a:rPr dirty="0"/>
+              <a:t>Batch size: 4096</a:t>
             </a:r>
           </a:p>
           <a:p>
@@ -14229,7 +14286,8 @@
               </a:defRPr>
             </a:pPr>
             <a:r>
-              <a:t>Split: 90/10 by H5 file</a:t>
+              <a:rPr dirty="0"/>
+              <a:t>Epochs: 50</a:t>
             </a:r>
           </a:p>
           <a:p>
@@ -14244,7 +14302,10 @@
                 <a:latin typeface="Calibri"/>
               </a:defRPr>
             </a:pPr>
-            <a:endParaRPr/>
+            <a:r>
+              <a:rPr dirty="0"/>
+              <a:t>Early stopping: patience 10</a:t>
+            </a:r>
           </a:p>
           <a:p>
             <a:pPr>
@@ -14259,7 +14320,8 @@
               </a:defRPr>
             </a:pPr>
             <a:r>
-              <a:t>Each layer:</a:t>
+              <a:rPr dirty="0"/>
+              <a:t>Split: 90/10 by H5 file</a:t>
             </a:r>
           </a:p>
           <a:p>
@@ -14274,9 +14336,7 @@
                 <a:latin typeface="Calibri"/>
               </a:defRPr>
             </a:pPr>
-            <a:r>
-              <a:t>  Linear → RMSNorm → GELU</a:t>
-            </a:r>
+            <a:endParaRPr dirty="0"/>
           </a:p>
           <a:p>
             <a:pPr>
@@ -14291,7 +14351,8 @@
               </a:defRPr>
             </a:pPr>
             <a:r>
-              <a:t>  + Dropout(0.2) in encoder</a:t>
+              <a:rPr dirty="0"/>
+              <a:t>Each layer:</a:t>
             </a:r>
           </a:p>
           <a:p>
@@ -14306,7 +14367,18 @@
                 <a:latin typeface="Calibri"/>
               </a:defRPr>
             </a:pPr>
-            <a:endParaRPr/>
+            <a:r>
+              <a:rPr dirty="0"/>
+              <a:t>  Linear → </a:t>
+            </a:r>
+            <a:r>
+              <a:rPr dirty="0" err="1"/>
+              <a:t>RMSNorm</a:t>
+            </a:r>
+            <a:r>
+              <a:rPr dirty="0"/>
+              <a:t> → GELU</a:t>
+            </a:r>
           </a:p>
           <a:p>
             <a:pPr>
@@ -14321,7 +14393,8 @@
               </a:defRPr>
             </a:pPr>
             <a:r>
-              <a:t>After training: FREEZE encoder</a:t>
+              <a:rPr dirty="0"/>
+              <a:t>  + Dropout(0.2) in encoder</a:t>
             </a:r>
           </a:p>
           <a:p>
@@ -14336,7 +14409,39 @@
                 <a:latin typeface="Calibri"/>
               </a:defRPr>
             </a:pPr>
-            <a:r>
+            <a:endParaRPr dirty="0"/>
+          </a:p>
+          <a:p>
+            <a:pPr>
+              <a:spcAft>
+                <a:spcPts val="439"/>
+              </a:spcAft>
+              <a:defRPr sz="1200" b="0">
+                <a:solidFill>
+                  <a:srgbClr val="555566"/>
+                </a:solidFill>
+                <a:latin typeface="Calibri"/>
+              </a:defRPr>
+            </a:pPr>
+            <a:r>
+              <a:rPr dirty="0"/>
+              <a:t>After training: FREEZE encoder</a:t>
+            </a:r>
+          </a:p>
+          <a:p>
+            <a:pPr>
+              <a:spcAft>
+                <a:spcPts val="439"/>
+              </a:spcAft>
+              <a:defRPr sz="1200" b="0">
+                <a:solidFill>
+                  <a:srgbClr val="555566"/>
+                </a:solidFill>
+                <a:latin typeface="Calibri"/>
+              </a:defRPr>
+            </a:pPr>
+            <a:r>
+              <a:rPr dirty="0"/>
               <a:t>Use as fixed projector in GNN</a:t>
             </a:r>
           </a:p>
@@ -14384,7 +14489,7 @@
         <p:spPr>
           <a:xfrm>
             <a:off x="457200" y="274320"/>
-            <a:ext cx="10972800" cy="548640"/>
+            <a:ext cx="10972800" cy="523220"/>
           </a:xfrm>
           <a:prstGeom prst="rect">
             <a:avLst/>
@@ -14397,7 +14502,7 @@
           </a:bodyPr>
           <a:lstStyle/>
           <a:p>
-            <a:pPr algn="l">
+            <a:pPr>
               <a:defRPr sz="2800" b="1">
                 <a:solidFill>
                   <a:srgbClr val="1A1A1A"/>
@@ -14406,44 +14511,18 @@
               </a:defRPr>
             </a:pPr>
             <a:r>
-              <a:t>Stage 3: Bipartite Graph Construction</a:t>
-            </a:r>
-          </a:p>
-        </p:txBody>
-      </p:sp>
-      <p:sp>
-        <p:nvSpPr>
-          <p:cNvPr id="3" name="TextBox 2"/>
-          <p:cNvSpPr txBox="1"/>
-          <p:nvPr/>
-        </p:nvSpPr>
-        <p:spPr>
-          <a:xfrm>
-            <a:off x="457200" y="822960"/>
-            <a:ext cx="10972800" cy="365760"/>
-          </a:xfrm>
-          <a:prstGeom prst="rect">
-            <a:avLst/>
-          </a:prstGeom>
-          <a:noFill/>
-        </p:spPr>
-        <p:txBody>
-          <a:bodyPr wrap="square">
-            <a:spAutoFit/>
-          </a:bodyPr>
-          <a:lstStyle/>
-          <a:p>
-            <a:pPr algn="l">
-              <a:defRPr sz="1400" b="0">
-                <a:solidFill>
-                  <a:srgbClr val="555566"/>
-                </a:solidFill>
-                <a:latin typeface="Calibri"/>
-              </a:defRPr>
-            </a:pPr>
-            <a:r>
-              <a:t>The core innovation: restrict edges to the tumor–NNP interface</a:t>
-            </a:r>
+              <a:rPr dirty="0"/>
+              <a:t>Stage 3: Graph Construction</a:t>
+            </a:r>
+            <a:r>
+              <a:rPr lang="tr-TR" dirty="0"/>
+              <a:t> (</a:t>
+            </a:r>
+            <a:r>
+              <a:rPr lang="en-US" dirty="0"/>
+              <a:t>Bipartite)</a:t>
+            </a:r>
+            <a:endParaRPr dirty="0"/>
           </a:p>
         </p:txBody>
       </p:sp>
@@ -14455,7 +14534,7 @@
         </p:nvSpPr>
         <p:spPr>
           <a:xfrm>
-            <a:off x="365760" y="1463040"/>
+            <a:off x="555765" y="2151809"/>
             <a:ext cx="2011680" cy="1645920"/>
           </a:xfrm>
           <a:prstGeom prst="roundRect">
@@ -14496,6 +14575,7 @@
               </a:defRPr>
             </a:pPr>
             <a:r>
+              <a:rPr dirty="0"/>
               <a:t>1. Hole Filling</a:t>
             </a:r>
           </a:p>
@@ -14508,14 +14588,21 @@
               </a:defRPr>
             </a:pPr>
             <a:r>
+              <a:rPr dirty="0"/>
               <a:t>Fill gaps inside</a:t>
             </a:r>
-            <a:br/>
-            <a:r>
+            <a:br>
+              <a:rPr dirty="0"/>
+            </a:br>
+            <a:r>
+              <a:rPr dirty="0"/>
               <a:t>tumor regions</a:t>
             </a:r>
-            <a:br/>
-            <a:r>
+            <a:br>
+              <a:rPr dirty="0"/>
+            </a:br>
+            <a:r>
+              <a:rPr dirty="0"/>
               <a:t>(morphological)</a:t>
             </a:r>
           </a:p>
@@ -14529,7 +14616,7 @@
         </p:nvSpPr>
         <p:spPr>
           <a:xfrm>
-            <a:off x="2377440" y="2011680"/>
+            <a:off x="2567445" y="2700449"/>
             <a:ext cx="228600" cy="228600"/>
           </a:xfrm>
           <a:prstGeom prst="rightArrow">
@@ -14573,7 +14660,7 @@
         </p:nvSpPr>
         <p:spPr>
           <a:xfrm>
-            <a:off x="2606040" y="1463040"/>
+            <a:off x="2796045" y="2151809"/>
             <a:ext cx="2011680" cy="1645920"/>
           </a:xfrm>
           <a:prstGeom prst="roundRect">
@@ -14614,6 +14701,7 @@
               </a:defRPr>
             </a:pPr>
             <a:r>
+              <a:rPr dirty="0"/>
               <a:t>2. Border Detection</a:t>
             </a:r>
           </a:p>
@@ -14626,14 +14714,33 @@
               </a:defRPr>
             </a:pPr>
             <a:r>
-              <a:t>Find PanNET patches</a:t>
-            </a:r>
-            <a:br/>
-            <a:r>
-              <a:t>with non-PanNET</a:t>
-            </a:r>
-            <a:br/>
-            <a:r>
+              <a:rPr dirty="0"/>
+              <a:t>Find </a:t>
+            </a:r>
+            <a:r>
+              <a:rPr dirty="0" err="1"/>
+              <a:t>PanNET</a:t>
+            </a:r>
+            <a:r>
+              <a:rPr dirty="0"/>
+              <a:t> patches</a:t>
+            </a:r>
+            <a:br>
+              <a:rPr dirty="0"/>
+            </a:br>
+            <a:r>
+              <a:rPr dirty="0"/>
+              <a:t>with non-</a:t>
+            </a:r>
+            <a:r>
+              <a:rPr dirty="0" err="1"/>
+              <a:t>PanNET</a:t>
+            </a:r>
+            <a:br>
+              <a:rPr dirty="0"/>
+            </a:br>
+            <a:r>
+              <a:rPr dirty="0"/>
               <a:t>8-neighbors</a:t>
             </a:r>
           </a:p>
@@ -14647,7 +14754,7 @@
         </p:nvSpPr>
         <p:spPr>
           <a:xfrm>
-            <a:off x="4617720" y="2011680"/>
+            <a:off x="4807725" y="2700449"/>
             <a:ext cx="228600" cy="228600"/>
           </a:xfrm>
           <a:prstGeom prst="rightArrow">
@@ -14691,7 +14798,7 @@
         </p:nvSpPr>
         <p:spPr>
           <a:xfrm>
-            <a:off x="4846320" y="1463040"/>
+            <a:off x="5036325" y="2151809"/>
             <a:ext cx="2011680" cy="1645920"/>
           </a:xfrm>
           <a:prstGeom prst="roundRect">
@@ -14732,6 +14839,7 @@
               </a:defRPr>
             </a:pPr>
             <a:r>
+              <a:rPr dirty="0"/>
               <a:t>3. NNP Inclusion</a:t>
             </a:r>
           </a:p>
@@ -14744,14 +14852,21 @@
               </a:defRPr>
             </a:pPr>
             <a:r>
+              <a:rPr dirty="0"/>
               <a:t>Include non-tumor</a:t>
             </a:r>
-            <a:br/>
-            <a:r>
+            <a:br>
+              <a:rPr dirty="0"/>
+            </a:br>
+            <a:r>
+              <a:rPr dirty="0"/>
               <a:t>patches within</a:t>
             </a:r>
-            <a:br/>
-            <a:r>
+            <a:br>
+              <a:rPr dirty="0"/>
+            </a:br>
+            <a:r>
+              <a:rPr dirty="0"/>
               <a:t>r hops of border</a:t>
             </a:r>
           </a:p>
@@ -14765,7 +14880,7 @@
         </p:nvSpPr>
         <p:spPr>
           <a:xfrm>
-            <a:off x="6858000" y="2011680"/>
+            <a:off x="7048005" y="2700449"/>
             <a:ext cx="228600" cy="228600"/>
           </a:xfrm>
           <a:prstGeom prst="rightArrow">
@@ -14809,7 +14924,7 @@
         </p:nvSpPr>
         <p:spPr>
           <a:xfrm>
-            <a:off x="7086600" y="1463040"/>
+            <a:off x="7276605" y="2151809"/>
             <a:ext cx="2011680" cy="1645920"/>
           </a:xfrm>
           <a:prstGeom prst="roundRect">
@@ -14883,7 +14998,7 @@
         </p:nvSpPr>
         <p:spPr>
           <a:xfrm>
-            <a:off x="9098280" y="2011680"/>
+            <a:off x="9288285" y="2700449"/>
             <a:ext cx="228600" cy="228600"/>
           </a:xfrm>
           <a:prstGeom prst="rightArrow">
@@ -14927,7 +15042,7 @@
         </p:nvSpPr>
         <p:spPr>
           <a:xfrm>
-            <a:off x="9326880" y="1463040"/>
+            <a:off x="9516885" y="2151809"/>
             <a:ext cx="2011680" cy="1645920"/>
           </a:xfrm>
           <a:prstGeom prst="roundRect">
@@ -14995,869 +15110,13 @@
       </p:sp>
       <p:sp>
         <p:nvSpPr>
-          <p:cNvPr id="13" name="TextBox 12"/>
-          <p:cNvSpPr txBox="1"/>
-          <p:nvPr/>
-        </p:nvSpPr>
-        <p:spPr>
-          <a:xfrm>
-            <a:off x="457200" y="3474720"/>
-            <a:ext cx="4572000" cy="365760"/>
-          </a:xfrm>
-          <a:prstGeom prst="rect">
-            <a:avLst/>
-          </a:prstGeom>
-          <a:noFill/>
-        </p:spPr>
-        <p:txBody>
-          <a:bodyPr wrap="square">
-            <a:spAutoFit/>
-          </a:bodyPr>
-          <a:lstStyle/>
-          <a:p>
-            <a:pPr algn="l">
-              <a:defRPr sz="1600" b="1">
-                <a:solidFill>
-                  <a:srgbClr val="1A1A1A"/>
-                </a:solidFill>
-                <a:latin typeface="Calibri"/>
-              </a:defRPr>
-            </a:pPr>
-            <a:r>
-              <a:t>Full Graph (all edges)</a:t>
-            </a:r>
-          </a:p>
-        </p:txBody>
-      </p:sp>
-      <p:sp>
-        <p:nvSpPr>
-          <p:cNvPr id="14" name="TextBox 13"/>
-          <p:cNvSpPr txBox="1"/>
-          <p:nvPr/>
-        </p:nvSpPr>
-        <p:spPr>
-          <a:xfrm>
-            <a:off x="6400800" y="3474720"/>
-            <a:ext cx="4572000" cy="365760"/>
-          </a:xfrm>
-          <a:prstGeom prst="rect">
-            <a:avLst/>
-          </a:prstGeom>
-          <a:noFill/>
-        </p:spPr>
-        <p:txBody>
-          <a:bodyPr wrap="square">
-            <a:spAutoFit/>
-          </a:bodyPr>
-          <a:lstStyle/>
-          <a:p>
-            <a:pPr algn="l">
-              <a:defRPr sz="1600" b="1">
-                <a:solidFill>
-                  <a:srgbClr val="1A1A1A"/>
-                </a:solidFill>
-                <a:latin typeface="Calibri"/>
-              </a:defRPr>
-            </a:pPr>
-            <a:r>
-              <a:t>Bipartite Graph (thesis approach)</a:t>
-            </a:r>
-          </a:p>
-        </p:txBody>
-      </p:sp>
-      <p:sp>
-        <p:nvSpPr>
-          <p:cNvPr id="15" name="Oval 14"/>
-          <p:cNvSpPr/>
-          <p:nvPr/>
-        </p:nvSpPr>
-        <p:spPr>
-          <a:xfrm>
-            <a:off x="914400" y="4023360"/>
-            <a:ext cx="365760" cy="365760"/>
-          </a:xfrm>
-          <a:prstGeom prst="ellipse">
-            <a:avLst/>
-          </a:prstGeom>
-          <a:solidFill>
-            <a:srgbClr val="27AE60"/>
-          </a:solidFill>
-          <a:ln>
-            <a:noFill/>
-          </a:ln>
-        </p:spPr>
-        <p:style>
-          <a:lnRef idx="1">
-            <a:schemeClr val="accent1"/>
-          </a:lnRef>
-          <a:fillRef idx="3">
-            <a:schemeClr val="accent1"/>
-          </a:fillRef>
-          <a:effectRef idx="2">
-            <a:schemeClr val="accent1"/>
-          </a:effectRef>
-          <a:fontRef idx="minor">
-            <a:schemeClr val="lt1"/>
-          </a:fontRef>
-        </p:style>
-        <p:txBody>
-          <a:bodyPr wrap="none" rtlCol="0" anchor="ctr"/>
-          <a:lstStyle/>
-          <a:p>
-            <a:pPr algn="ctr">
-              <a:spcBef>
-                <a:spcPts val="0"/>
-              </a:spcBef>
-              <a:spcAft>
-                <a:spcPts val="0"/>
-              </a:spcAft>
-              <a:defRPr sz="900" b="1">
-                <a:solidFill>
-                  <a:srgbClr val="FFFFFF"/>
-                </a:solidFill>
-              </a:defRPr>
-            </a:pPr>
-            <a:r>
-              <a:t>T</a:t>
-            </a:r>
-          </a:p>
-        </p:txBody>
-      </p:sp>
-      <p:sp>
-        <p:nvSpPr>
-          <p:cNvPr id="16" name="Oval 15"/>
-          <p:cNvSpPr/>
-          <p:nvPr/>
-        </p:nvSpPr>
-        <p:spPr>
-          <a:xfrm>
-            <a:off x="1645920" y="4023360"/>
-            <a:ext cx="365760" cy="365760"/>
-          </a:xfrm>
-          <a:prstGeom prst="ellipse">
-            <a:avLst/>
-          </a:prstGeom>
-          <a:solidFill>
-            <a:srgbClr val="27AE60"/>
-          </a:solidFill>
-          <a:ln>
-            <a:noFill/>
-          </a:ln>
-        </p:spPr>
-        <p:style>
-          <a:lnRef idx="1">
-            <a:schemeClr val="accent1"/>
-          </a:lnRef>
-          <a:fillRef idx="3">
-            <a:schemeClr val="accent1"/>
-          </a:fillRef>
-          <a:effectRef idx="2">
-            <a:schemeClr val="accent1"/>
-          </a:effectRef>
-          <a:fontRef idx="minor">
-            <a:schemeClr val="lt1"/>
-          </a:fontRef>
-        </p:style>
-        <p:txBody>
-          <a:bodyPr wrap="none" rtlCol="0" anchor="ctr"/>
-          <a:lstStyle/>
-          <a:p>
-            <a:pPr algn="ctr">
-              <a:spcBef>
-                <a:spcPts val="0"/>
-              </a:spcBef>
-              <a:spcAft>
-                <a:spcPts val="0"/>
-              </a:spcAft>
-              <a:defRPr sz="900" b="1">
-                <a:solidFill>
-                  <a:srgbClr val="FFFFFF"/>
-                </a:solidFill>
-              </a:defRPr>
-            </a:pPr>
-            <a:r>
-              <a:t>T</a:t>
-            </a:r>
-          </a:p>
-        </p:txBody>
-      </p:sp>
-      <p:sp>
-        <p:nvSpPr>
-          <p:cNvPr id="17" name="Oval 16"/>
-          <p:cNvSpPr/>
-          <p:nvPr/>
-        </p:nvSpPr>
-        <p:spPr>
-          <a:xfrm>
-            <a:off x="2377440" y="4023360"/>
-            <a:ext cx="365760" cy="365760"/>
-          </a:xfrm>
-          <a:prstGeom prst="ellipse">
-            <a:avLst/>
-          </a:prstGeom>
-          <a:solidFill>
-            <a:srgbClr val="27AE60"/>
-          </a:solidFill>
-          <a:ln>
-            <a:noFill/>
-          </a:ln>
-        </p:spPr>
-        <p:style>
-          <a:lnRef idx="1">
-            <a:schemeClr val="accent1"/>
-          </a:lnRef>
-          <a:fillRef idx="3">
-            <a:schemeClr val="accent1"/>
-          </a:fillRef>
-          <a:effectRef idx="2">
-            <a:schemeClr val="accent1"/>
-          </a:effectRef>
-          <a:fontRef idx="minor">
-            <a:schemeClr val="lt1"/>
-          </a:fontRef>
-        </p:style>
-        <p:txBody>
-          <a:bodyPr wrap="none" rtlCol="0" anchor="ctr"/>
-          <a:lstStyle/>
-          <a:p>
-            <a:pPr algn="ctr">
-              <a:spcBef>
-                <a:spcPts val="0"/>
-              </a:spcBef>
-              <a:spcAft>
-                <a:spcPts val="0"/>
-              </a:spcAft>
-              <a:defRPr sz="900" b="1">
-                <a:solidFill>
-                  <a:srgbClr val="FFFFFF"/>
-                </a:solidFill>
-              </a:defRPr>
-            </a:pPr>
-            <a:r>
-              <a:t>T</a:t>
-            </a:r>
-          </a:p>
-        </p:txBody>
-      </p:sp>
-      <p:sp>
-        <p:nvSpPr>
-          <p:cNvPr id="18" name="Oval 17"/>
-          <p:cNvSpPr/>
-          <p:nvPr/>
-        </p:nvSpPr>
-        <p:spPr>
-          <a:xfrm>
-            <a:off x="914400" y="4754880"/>
-            <a:ext cx="365760" cy="365760"/>
-          </a:xfrm>
-          <a:prstGeom prst="ellipse">
-            <a:avLst/>
-          </a:prstGeom>
-          <a:solidFill>
-            <a:srgbClr val="C0392B"/>
-          </a:solidFill>
-          <a:ln>
-            <a:noFill/>
-          </a:ln>
-        </p:spPr>
-        <p:style>
-          <a:lnRef idx="1">
-            <a:schemeClr val="accent1"/>
-          </a:lnRef>
-          <a:fillRef idx="3">
-            <a:schemeClr val="accent1"/>
-          </a:fillRef>
-          <a:effectRef idx="2">
-            <a:schemeClr val="accent1"/>
-          </a:effectRef>
-          <a:fontRef idx="minor">
-            <a:schemeClr val="lt1"/>
-          </a:fontRef>
-        </p:style>
-        <p:txBody>
-          <a:bodyPr wrap="none" rtlCol="0" anchor="ctr"/>
-          <a:lstStyle/>
-          <a:p>
-            <a:pPr algn="ctr">
-              <a:spcBef>
-                <a:spcPts val="0"/>
-              </a:spcBef>
-              <a:spcAft>
-                <a:spcPts val="0"/>
-              </a:spcAft>
-              <a:defRPr sz="900" b="1">
-                <a:solidFill>
-                  <a:srgbClr val="FFFFFF"/>
-                </a:solidFill>
-              </a:defRPr>
-            </a:pPr>
-            <a:r>
-              <a:t>S</a:t>
-            </a:r>
-          </a:p>
-        </p:txBody>
-      </p:sp>
-      <p:sp>
-        <p:nvSpPr>
-          <p:cNvPr id="19" name="Oval 18"/>
-          <p:cNvSpPr/>
-          <p:nvPr/>
-        </p:nvSpPr>
-        <p:spPr>
-          <a:xfrm>
-            <a:off x="1645920" y="4754880"/>
-            <a:ext cx="365760" cy="365760"/>
-          </a:xfrm>
-          <a:prstGeom prst="ellipse">
-            <a:avLst/>
-          </a:prstGeom>
-          <a:solidFill>
-            <a:srgbClr val="C0392B"/>
-          </a:solidFill>
-          <a:ln>
-            <a:noFill/>
-          </a:ln>
-        </p:spPr>
-        <p:style>
-          <a:lnRef idx="1">
-            <a:schemeClr val="accent1"/>
-          </a:lnRef>
-          <a:fillRef idx="3">
-            <a:schemeClr val="accent1"/>
-          </a:fillRef>
-          <a:effectRef idx="2">
-            <a:schemeClr val="accent1"/>
-          </a:effectRef>
-          <a:fontRef idx="minor">
-            <a:schemeClr val="lt1"/>
-          </a:fontRef>
-        </p:style>
-        <p:txBody>
-          <a:bodyPr wrap="none" rtlCol="0" anchor="ctr"/>
-          <a:lstStyle/>
-          <a:p>
-            <a:pPr algn="ctr">
-              <a:spcBef>
-                <a:spcPts val="0"/>
-              </a:spcBef>
-              <a:spcAft>
-                <a:spcPts val="0"/>
-              </a:spcAft>
-              <a:defRPr sz="900" b="1">
-                <a:solidFill>
-                  <a:srgbClr val="FFFFFF"/>
-                </a:solidFill>
-              </a:defRPr>
-            </a:pPr>
-            <a:r>
-              <a:t>S</a:t>
-            </a:r>
-          </a:p>
-        </p:txBody>
-      </p:sp>
-      <p:sp>
-        <p:nvSpPr>
-          <p:cNvPr id="20" name="Oval 19"/>
-          <p:cNvSpPr/>
-          <p:nvPr/>
-        </p:nvSpPr>
-        <p:spPr>
-          <a:xfrm>
-            <a:off x="2377440" y="4754880"/>
-            <a:ext cx="365760" cy="365760"/>
-          </a:xfrm>
-          <a:prstGeom prst="ellipse">
-            <a:avLst/>
-          </a:prstGeom>
-          <a:solidFill>
-            <a:srgbClr val="C0392B"/>
-          </a:solidFill>
-          <a:ln>
-            <a:noFill/>
-          </a:ln>
-        </p:spPr>
-        <p:style>
-          <a:lnRef idx="1">
-            <a:schemeClr val="accent1"/>
-          </a:lnRef>
-          <a:fillRef idx="3">
-            <a:schemeClr val="accent1"/>
-          </a:fillRef>
-          <a:effectRef idx="2">
-            <a:schemeClr val="accent1"/>
-          </a:effectRef>
-          <a:fontRef idx="minor">
-            <a:schemeClr val="lt1"/>
-          </a:fontRef>
-        </p:style>
-        <p:txBody>
-          <a:bodyPr wrap="none" rtlCol="0" anchor="ctr"/>
-          <a:lstStyle/>
-          <a:p>
-            <a:pPr algn="ctr">
-              <a:spcBef>
-                <a:spcPts val="0"/>
-              </a:spcBef>
-              <a:spcAft>
-                <a:spcPts val="0"/>
-              </a:spcAft>
-              <a:defRPr sz="900" b="1">
-                <a:solidFill>
-                  <a:srgbClr val="FFFFFF"/>
-                </a:solidFill>
-              </a:defRPr>
-            </a:pPr>
-            <a:r>
-              <a:t>S</a:t>
-            </a:r>
-          </a:p>
-        </p:txBody>
-      </p:sp>
-      <p:sp>
-        <p:nvSpPr>
-          <p:cNvPr id="21" name="TextBox 20"/>
-          <p:cNvSpPr txBox="1"/>
-          <p:nvPr/>
-        </p:nvSpPr>
-        <p:spPr>
-          <a:xfrm>
-            <a:off x="731520" y="5303520"/>
-            <a:ext cx="3200400" cy="731520"/>
-          </a:xfrm>
-          <a:prstGeom prst="rect">
-            <a:avLst/>
-          </a:prstGeom>
-          <a:noFill/>
-        </p:spPr>
-        <p:txBody>
-          <a:bodyPr wrap="square">
-            <a:spAutoFit/>
-          </a:bodyPr>
-          <a:lstStyle/>
-          <a:p>
-            <a:pPr algn="l">
-              <a:defRPr sz="1100" b="0">
-                <a:solidFill>
-                  <a:srgbClr val="C0392B"/>
-                </a:solidFill>
-                <a:latin typeface="Calibri"/>
-              </a:defRPr>
-            </a:pPr>
-            <a:r>
-              <a:t>All edges: T↔T, S↔S, T↔S</a:t>
-            </a:r>
-            <a:br/>
-            <a:r>
-              <a:t>Noisy — wastes capacity on</a:t>
-            </a:r>
-            <a:br/>
-            <a:r>
-              <a:t>homogeneous interactions</a:t>
-            </a:r>
-          </a:p>
-        </p:txBody>
-      </p:sp>
-      <p:sp>
-        <p:nvSpPr>
-          <p:cNvPr id="22" name="Oval 21"/>
-          <p:cNvSpPr/>
-          <p:nvPr/>
-        </p:nvSpPr>
-        <p:spPr>
-          <a:xfrm>
-            <a:off x="6858000" y="4023360"/>
-            <a:ext cx="365760" cy="365760"/>
-          </a:xfrm>
-          <a:prstGeom prst="ellipse">
-            <a:avLst/>
-          </a:prstGeom>
-          <a:solidFill>
-            <a:srgbClr val="27AE60"/>
-          </a:solidFill>
-          <a:ln>
-            <a:noFill/>
-          </a:ln>
-        </p:spPr>
-        <p:style>
-          <a:lnRef idx="1">
-            <a:schemeClr val="accent1"/>
-          </a:lnRef>
-          <a:fillRef idx="3">
-            <a:schemeClr val="accent1"/>
-          </a:fillRef>
-          <a:effectRef idx="2">
-            <a:schemeClr val="accent1"/>
-          </a:effectRef>
-          <a:fontRef idx="minor">
-            <a:schemeClr val="lt1"/>
-          </a:fontRef>
-        </p:style>
-        <p:txBody>
-          <a:bodyPr wrap="none" rtlCol="0" anchor="ctr"/>
-          <a:lstStyle/>
-          <a:p>
-            <a:pPr algn="ctr">
-              <a:spcBef>
-                <a:spcPts val="0"/>
-              </a:spcBef>
-              <a:spcAft>
-                <a:spcPts val="0"/>
-              </a:spcAft>
-              <a:defRPr sz="900" b="1">
-                <a:solidFill>
-                  <a:srgbClr val="FFFFFF"/>
-                </a:solidFill>
-              </a:defRPr>
-            </a:pPr>
-            <a:r>
-              <a:t>T</a:t>
-            </a:r>
-          </a:p>
-        </p:txBody>
-      </p:sp>
-      <p:sp>
-        <p:nvSpPr>
-          <p:cNvPr id="23" name="Oval 22"/>
-          <p:cNvSpPr/>
-          <p:nvPr/>
-        </p:nvSpPr>
-        <p:spPr>
-          <a:xfrm>
-            <a:off x="7589520" y="4023360"/>
-            <a:ext cx="365760" cy="365760"/>
-          </a:xfrm>
-          <a:prstGeom prst="ellipse">
-            <a:avLst/>
-          </a:prstGeom>
-          <a:solidFill>
-            <a:srgbClr val="27AE60"/>
-          </a:solidFill>
-          <a:ln>
-            <a:noFill/>
-          </a:ln>
-        </p:spPr>
-        <p:style>
-          <a:lnRef idx="1">
-            <a:schemeClr val="accent1"/>
-          </a:lnRef>
-          <a:fillRef idx="3">
-            <a:schemeClr val="accent1"/>
-          </a:fillRef>
-          <a:effectRef idx="2">
-            <a:schemeClr val="accent1"/>
-          </a:effectRef>
-          <a:fontRef idx="minor">
-            <a:schemeClr val="lt1"/>
-          </a:fontRef>
-        </p:style>
-        <p:txBody>
-          <a:bodyPr wrap="none" rtlCol="0" anchor="ctr"/>
-          <a:lstStyle/>
-          <a:p>
-            <a:pPr algn="ctr">
-              <a:spcBef>
-                <a:spcPts val="0"/>
-              </a:spcBef>
-              <a:spcAft>
-                <a:spcPts val="0"/>
-              </a:spcAft>
-              <a:defRPr sz="900" b="1">
-                <a:solidFill>
-                  <a:srgbClr val="FFFFFF"/>
-                </a:solidFill>
-              </a:defRPr>
-            </a:pPr>
-            <a:r>
-              <a:t>T</a:t>
-            </a:r>
-          </a:p>
-        </p:txBody>
-      </p:sp>
-      <p:sp>
-        <p:nvSpPr>
-          <p:cNvPr id="24" name="Oval 23"/>
-          <p:cNvSpPr/>
-          <p:nvPr/>
-        </p:nvSpPr>
-        <p:spPr>
-          <a:xfrm>
-            <a:off x="8321040" y="4023360"/>
-            <a:ext cx="365760" cy="365760"/>
-          </a:xfrm>
-          <a:prstGeom prst="ellipse">
-            <a:avLst/>
-          </a:prstGeom>
-          <a:solidFill>
-            <a:srgbClr val="27AE60"/>
-          </a:solidFill>
-          <a:ln>
-            <a:noFill/>
-          </a:ln>
-        </p:spPr>
-        <p:style>
-          <a:lnRef idx="1">
-            <a:schemeClr val="accent1"/>
-          </a:lnRef>
-          <a:fillRef idx="3">
-            <a:schemeClr val="accent1"/>
-          </a:fillRef>
-          <a:effectRef idx="2">
-            <a:schemeClr val="accent1"/>
-          </a:effectRef>
-          <a:fontRef idx="minor">
-            <a:schemeClr val="lt1"/>
-          </a:fontRef>
-        </p:style>
-        <p:txBody>
-          <a:bodyPr wrap="none" rtlCol="0" anchor="ctr"/>
-          <a:lstStyle/>
-          <a:p>
-            <a:pPr algn="ctr">
-              <a:spcBef>
-                <a:spcPts val="0"/>
-              </a:spcBef>
-              <a:spcAft>
-                <a:spcPts val="0"/>
-              </a:spcAft>
-              <a:defRPr sz="900" b="1">
-                <a:solidFill>
-                  <a:srgbClr val="FFFFFF"/>
-                </a:solidFill>
-              </a:defRPr>
-            </a:pPr>
-            <a:r>
-              <a:t>T</a:t>
-            </a:r>
-          </a:p>
-        </p:txBody>
-      </p:sp>
-      <p:sp>
-        <p:nvSpPr>
-          <p:cNvPr id="25" name="Oval 24"/>
-          <p:cNvSpPr/>
-          <p:nvPr/>
-        </p:nvSpPr>
-        <p:spPr>
-          <a:xfrm>
-            <a:off x="6858000" y="4754880"/>
-            <a:ext cx="365760" cy="365760"/>
-          </a:xfrm>
-          <a:prstGeom prst="ellipse">
-            <a:avLst/>
-          </a:prstGeom>
-          <a:solidFill>
-            <a:srgbClr val="C0392B"/>
-          </a:solidFill>
-          <a:ln>
-            <a:noFill/>
-          </a:ln>
-        </p:spPr>
-        <p:style>
-          <a:lnRef idx="1">
-            <a:schemeClr val="accent1"/>
-          </a:lnRef>
-          <a:fillRef idx="3">
-            <a:schemeClr val="accent1"/>
-          </a:fillRef>
-          <a:effectRef idx="2">
-            <a:schemeClr val="accent1"/>
-          </a:effectRef>
-          <a:fontRef idx="minor">
-            <a:schemeClr val="lt1"/>
-          </a:fontRef>
-        </p:style>
-        <p:txBody>
-          <a:bodyPr wrap="none" rtlCol="0" anchor="ctr"/>
-          <a:lstStyle/>
-          <a:p>
-            <a:pPr algn="ctr">
-              <a:spcBef>
-                <a:spcPts val="0"/>
-              </a:spcBef>
-              <a:spcAft>
-                <a:spcPts val="0"/>
-              </a:spcAft>
-              <a:defRPr sz="900" b="1">
-                <a:solidFill>
-                  <a:srgbClr val="FFFFFF"/>
-                </a:solidFill>
-              </a:defRPr>
-            </a:pPr>
-            <a:r>
-              <a:t>S</a:t>
-            </a:r>
-          </a:p>
-        </p:txBody>
-      </p:sp>
-      <p:sp>
-        <p:nvSpPr>
-          <p:cNvPr id="26" name="Oval 25"/>
-          <p:cNvSpPr/>
-          <p:nvPr/>
-        </p:nvSpPr>
-        <p:spPr>
-          <a:xfrm>
-            <a:off x="7589520" y="4754880"/>
-            <a:ext cx="365760" cy="365760"/>
-          </a:xfrm>
-          <a:prstGeom prst="ellipse">
-            <a:avLst/>
-          </a:prstGeom>
-          <a:solidFill>
-            <a:srgbClr val="C0392B"/>
-          </a:solidFill>
-          <a:ln>
-            <a:noFill/>
-          </a:ln>
-        </p:spPr>
-        <p:style>
-          <a:lnRef idx="1">
-            <a:schemeClr val="accent1"/>
-          </a:lnRef>
-          <a:fillRef idx="3">
-            <a:schemeClr val="accent1"/>
-          </a:fillRef>
-          <a:effectRef idx="2">
-            <a:schemeClr val="accent1"/>
-          </a:effectRef>
-          <a:fontRef idx="minor">
-            <a:schemeClr val="lt1"/>
-          </a:fontRef>
-        </p:style>
-        <p:txBody>
-          <a:bodyPr wrap="none" rtlCol="0" anchor="ctr"/>
-          <a:lstStyle/>
-          <a:p>
-            <a:pPr algn="ctr">
-              <a:spcBef>
-                <a:spcPts val="0"/>
-              </a:spcBef>
-              <a:spcAft>
-                <a:spcPts val="0"/>
-              </a:spcAft>
-              <a:defRPr sz="900" b="1">
-                <a:solidFill>
-                  <a:srgbClr val="FFFFFF"/>
-                </a:solidFill>
-              </a:defRPr>
-            </a:pPr>
-            <a:r>
-              <a:t>S</a:t>
-            </a:r>
-          </a:p>
-        </p:txBody>
-      </p:sp>
-      <p:sp>
-        <p:nvSpPr>
-          <p:cNvPr id="27" name="Oval 26"/>
-          <p:cNvSpPr/>
-          <p:nvPr/>
-        </p:nvSpPr>
-        <p:spPr>
-          <a:xfrm>
-            <a:off x="8321040" y="4754880"/>
-            <a:ext cx="365760" cy="365760"/>
-          </a:xfrm>
-          <a:prstGeom prst="ellipse">
-            <a:avLst/>
-          </a:prstGeom>
-          <a:solidFill>
-            <a:srgbClr val="C0392B"/>
-          </a:solidFill>
-          <a:ln>
-            <a:noFill/>
-          </a:ln>
-        </p:spPr>
-        <p:style>
-          <a:lnRef idx="1">
-            <a:schemeClr val="accent1"/>
-          </a:lnRef>
-          <a:fillRef idx="3">
-            <a:schemeClr val="accent1"/>
-          </a:fillRef>
-          <a:effectRef idx="2">
-            <a:schemeClr val="accent1"/>
-          </a:effectRef>
-          <a:fontRef idx="minor">
-            <a:schemeClr val="lt1"/>
-          </a:fontRef>
-        </p:style>
-        <p:txBody>
-          <a:bodyPr wrap="none" rtlCol="0" anchor="ctr"/>
-          <a:lstStyle/>
-          <a:p>
-            <a:pPr algn="ctr">
-              <a:spcBef>
-                <a:spcPts val="0"/>
-              </a:spcBef>
-              <a:spcAft>
-                <a:spcPts val="0"/>
-              </a:spcAft>
-              <a:defRPr sz="900" b="1">
-                <a:solidFill>
-                  <a:srgbClr val="FFFFFF"/>
-                </a:solidFill>
-              </a:defRPr>
-            </a:pPr>
-            <a:r>
-              <a:t>S</a:t>
-            </a:r>
-          </a:p>
-        </p:txBody>
-      </p:sp>
-      <p:sp>
-        <p:nvSpPr>
-          <p:cNvPr id="28" name="TextBox 27"/>
-          <p:cNvSpPr txBox="1"/>
-          <p:nvPr/>
-        </p:nvSpPr>
-        <p:spPr>
-          <a:xfrm>
-            <a:off x="6675120" y="5303520"/>
-            <a:ext cx="3200400" cy="731520"/>
-          </a:xfrm>
-          <a:prstGeom prst="rect">
-            <a:avLst/>
-          </a:prstGeom>
-          <a:noFill/>
-        </p:spPr>
-        <p:txBody>
-          <a:bodyPr wrap="square">
-            <a:spAutoFit/>
-          </a:bodyPr>
-          <a:lstStyle/>
-          <a:p>
-            <a:pPr algn="l">
-              <a:defRPr sz="1100" b="0">
-                <a:solidFill>
-                  <a:srgbClr val="27AE60"/>
-                </a:solidFill>
-                <a:latin typeface="Calibri"/>
-              </a:defRPr>
-            </a:pPr>
-            <a:r>
-              <a:t>Only T↔S edges</a:t>
-            </a:r>
-            <a:br/>
-            <a:r>
-              <a:t>Forces learning at the</a:t>
-            </a:r>
-            <a:br/>
-            <a:r>
-              <a:t>tumor–NNP interface</a:t>
-            </a:r>
-          </a:p>
-        </p:txBody>
-      </p:sp>
-      <p:sp>
-        <p:nvSpPr>
           <p:cNvPr id="29" name="Rounded Rectangle 28"/>
           <p:cNvSpPr/>
           <p:nvPr/>
         </p:nvSpPr>
         <p:spPr>
           <a:xfrm>
-            <a:off x="457200" y="5943600"/>
+            <a:off x="472440" y="5035138"/>
             <a:ext cx="11247120" cy="640080"/>
           </a:xfrm>
           <a:prstGeom prst="roundRect">
@@ -19848,7 +19107,7 @@
         </p:nvSpPr>
         <p:spPr>
           <a:xfrm>
-            <a:off x="2743200" y="5029200"/>
+            <a:off x="2966484" y="4553713"/>
             <a:ext cx="228600" cy="228600"/>
           </a:xfrm>
           <a:prstGeom prst="ellipse">
@@ -19892,7 +19151,7 @@
         </p:nvSpPr>
         <p:spPr>
           <a:xfrm>
-            <a:off x="3017520" y="5029200"/>
+            <a:off x="3240804" y="4553713"/>
             <a:ext cx="1828800" cy="274320"/>
           </a:xfrm>
           <a:prstGeom prst="rect">
@@ -19928,7 +19187,7 @@
         </p:nvSpPr>
         <p:spPr>
           <a:xfrm>
-            <a:off x="4572000" y="5029200"/>
+            <a:off x="4795284" y="4553713"/>
             <a:ext cx="228600" cy="228600"/>
           </a:xfrm>
           <a:prstGeom prst="ellipse">
@@ -19972,7 +19231,7 @@
         </p:nvSpPr>
         <p:spPr>
           <a:xfrm>
-            <a:off x="4846320" y="5029200"/>
+            <a:off x="5069604" y="4553713"/>
             <a:ext cx="1828800" cy="274320"/>
           </a:xfrm>
           <a:prstGeom prst="rect">
@@ -20008,7 +19267,7 @@
         </p:nvSpPr>
         <p:spPr>
           <a:xfrm>
-            <a:off x="6858000" y="5029200"/>
+            <a:off x="7081284" y="4553713"/>
             <a:ext cx="228600" cy="228600"/>
           </a:xfrm>
           <a:prstGeom prst="ellipse">
@@ -20052,7 +19311,7 @@
         </p:nvSpPr>
         <p:spPr>
           <a:xfrm>
-            <a:off x="7132320" y="5029200"/>
+            <a:off x="7355604" y="4553713"/>
             <a:ext cx="1828800" cy="274320"/>
           </a:xfrm>
           <a:prstGeom prst="rect">
@@ -20082,49 +19341,13 @@
       </p:sp>
       <p:sp>
         <p:nvSpPr>
-          <p:cNvPr id="98" name="TextBox 97"/>
-          <p:cNvSpPr txBox="1"/>
-          <p:nvPr/>
-        </p:nvSpPr>
-        <p:spPr>
-          <a:xfrm>
-            <a:off x="457200" y="5486400"/>
-            <a:ext cx="10972800" cy="365760"/>
-          </a:xfrm>
-          <a:prstGeom prst="rect">
-            <a:avLst/>
-          </a:prstGeom>
-          <a:noFill/>
-        </p:spPr>
-        <p:txBody>
-          <a:bodyPr wrap="square">
-            <a:spAutoFit/>
-          </a:bodyPr>
-          <a:lstStyle/>
-          <a:p>
-            <a:pPr algn="ctr">
-              <a:defRPr sz="1300" b="0">
-                <a:solidFill>
-                  <a:srgbClr val="555566"/>
-                </a:solidFill>
-                <a:latin typeface="Calibri"/>
-              </a:defRPr>
-            </a:pPr>
-            <a:r>
-              <a:t>Distance metric: Chebyshev (L∞) = max(|Δx|, |Δy|) / patch_size</a:t>
-            </a:r>
-          </a:p>
-        </p:txBody>
-      </p:sp>
-      <p:sp>
-        <p:nvSpPr>
           <p:cNvPr id="99" name="Rounded Rectangle 98"/>
           <p:cNvSpPr/>
           <p:nvPr/>
         </p:nvSpPr>
         <p:spPr>
           <a:xfrm>
-            <a:off x="457200" y="5943600"/>
+            <a:off x="472440" y="5263116"/>
             <a:ext cx="11247120" cy="640080"/>
           </a:xfrm>
           <a:prstGeom prst="roundRect">
@@ -20165,7 +19388,8 @@
               </a:defRPr>
             </a:pPr>
             <a:r>
-              <a:t>Thesis finding: Larger radius r consistently improves performance. r=3 is optimal (Table 5.5)</a:t>
+              <a:rPr dirty="0"/>
+              <a:t>Thesis finding: r=3 is optimal (Table 5.5)</a:t>
             </a:r>
           </a:p>
         </p:txBody>
@@ -20288,20 +19512,30 @@
               </a:defRPr>
             </a:pPr>
             <a:r>
+              <a:rPr dirty="0"/>
               <a:t>Frozen</a:t>
             </a:r>
-            <a:br/>
-            <a:r>
+            <a:br>
+              <a:rPr dirty="0"/>
+            </a:br>
+            <a:r>
+              <a:rPr dirty="0"/>
               <a:t>Projector</a:t>
             </a:r>
           </a:p>
           <a:p>
-            <a:br/>
-            <a:r>
+            <a:br>
+              <a:rPr dirty="0"/>
+            </a:br>
+            <a:r>
+              <a:rPr dirty="0"/>
               <a:t>AE Encoder</a:t>
             </a:r>
-            <a:br/>
-            <a:r>
+            <a:br>
+              <a:rPr dirty="0"/>
+            </a:br>
+            <a:r>
+              <a:rPr dirty="0"/>
               <a:t>1280 → 256</a:t>
             </a:r>
           </a:p>

</xml_diff>